<commit_message>
fix(viz): redesign final figures and refresh deliverables
</commit_message>
<xml_diff>
--- a/outputs/final/submission/final_slides.pptx
+++ b/outputs/final/submission/final_slides.pptx
@@ -2207,8 +2207,8 @@
         </p:blipFill>
         <p:spPr>
           <a:xfrm>
-            <a:off x="5989320" y="3218307"/>
-            <a:ext cx="5577840" cy="1162050"/>
+            <a:off x="5989320" y="2959756"/>
+            <a:ext cx="5577840" cy="1679151"/>
           </a:xfrm>
           <a:prstGeom prst="rect">
             <a:avLst/>
@@ -3705,8 +3705,8 @@
         </p:blipFill>
         <p:spPr>
           <a:xfrm>
-            <a:off x="658368" y="2034540"/>
-            <a:ext cx="5760720" cy="3840480"/>
+            <a:off x="658368" y="2041191"/>
+            <a:ext cx="5760720" cy="3827179"/>
           </a:xfrm>
           <a:prstGeom prst="rect">
             <a:avLst/>
@@ -4183,8 +4183,8 @@
         </p:blipFill>
         <p:spPr>
           <a:xfrm>
-            <a:off x="822960" y="2628900"/>
-            <a:ext cx="4389120" cy="2194560"/>
+            <a:off x="822960" y="2532131"/>
+            <a:ext cx="4389120" cy="2388098"/>
           </a:xfrm>
           <a:prstGeom prst="rect">
             <a:avLst/>

</xml_diff>